<commit_message>
update in power point
</commit_message>
<xml_diff>
--- a/figures/resources/sample_preparation.pptx
+++ b/figures/resources/sample_preparation.pptx
@@ -7,7 +7,6 @@
   <p:sldIdLst>
     <p:sldId id="256" r:id="rId2"/>
     <p:sldId id="258" r:id="rId3"/>
-    <p:sldId id="257" r:id="rId4"/>
   </p:sldIdLst>
   <p:sldSz cx="24384000" cy="13716000"/>
   <p:notesSz cx="6858000" cy="9144000"/>
@@ -245,7 +244,7 @@
           <a:p>
             <a:fld id="{2CACDD28-0A48-0E47-898B-1110AC508CAE}" type="datetimeFigureOut">
               <a:rPr lang="en-DE" smtClean="0"/>
-              <a:t>06/10/2026</a:t>
+              <a:t>06/11/2026</a:t>
             </a:fld>
             <a:endParaRPr lang="en-DE"/>
           </a:p>
@@ -415,7 +414,7 @@
           <a:p>
             <a:fld id="{2CACDD28-0A48-0E47-898B-1110AC508CAE}" type="datetimeFigureOut">
               <a:rPr lang="en-DE" smtClean="0"/>
-              <a:t>06/10/2026</a:t>
+              <a:t>06/11/2026</a:t>
             </a:fld>
             <a:endParaRPr lang="en-DE"/>
           </a:p>
@@ -595,7 +594,7 @@
           <a:p>
             <a:fld id="{2CACDD28-0A48-0E47-898B-1110AC508CAE}" type="datetimeFigureOut">
               <a:rPr lang="en-DE" smtClean="0"/>
-              <a:t>06/10/2026</a:t>
+              <a:t>06/11/2026</a:t>
             </a:fld>
             <a:endParaRPr lang="en-DE"/>
           </a:p>
@@ -765,7 +764,7 @@
           <a:p>
             <a:fld id="{2CACDD28-0A48-0E47-898B-1110AC508CAE}" type="datetimeFigureOut">
               <a:rPr lang="en-DE" smtClean="0"/>
-              <a:t>06/10/2026</a:t>
+              <a:t>06/11/2026</a:t>
             </a:fld>
             <a:endParaRPr lang="en-DE"/>
           </a:p>
@@ -1011,7 +1010,7 @@
           <a:p>
             <a:fld id="{2CACDD28-0A48-0E47-898B-1110AC508CAE}" type="datetimeFigureOut">
               <a:rPr lang="en-DE" smtClean="0"/>
-              <a:t>06/10/2026</a:t>
+              <a:t>06/11/2026</a:t>
             </a:fld>
             <a:endParaRPr lang="en-DE"/>
           </a:p>
@@ -1243,7 +1242,7 @@
           <a:p>
             <a:fld id="{2CACDD28-0A48-0E47-898B-1110AC508CAE}" type="datetimeFigureOut">
               <a:rPr lang="en-DE" smtClean="0"/>
-              <a:t>06/10/2026</a:t>
+              <a:t>06/11/2026</a:t>
             </a:fld>
             <a:endParaRPr lang="en-DE"/>
           </a:p>
@@ -1610,7 +1609,7 @@
           <a:p>
             <a:fld id="{2CACDD28-0A48-0E47-898B-1110AC508CAE}" type="datetimeFigureOut">
               <a:rPr lang="en-DE" smtClean="0"/>
-              <a:t>06/10/2026</a:t>
+              <a:t>06/11/2026</a:t>
             </a:fld>
             <a:endParaRPr lang="en-DE"/>
           </a:p>
@@ -1728,7 +1727,7 @@
           <a:p>
             <a:fld id="{2CACDD28-0A48-0E47-898B-1110AC508CAE}" type="datetimeFigureOut">
               <a:rPr lang="en-DE" smtClean="0"/>
-              <a:t>06/10/2026</a:t>
+              <a:t>06/11/2026</a:t>
             </a:fld>
             <a:endParaRPr lang="en-DE"/>
           </a:p>
@@ -1823,7 +1822,7 @@
           <a:p>
             <a:fld id="{2CACDD28-0A48-0E47-898B-1110AC508CAE}" type="datetimeFigureOut">
               <a:rPr lang="en-DE" smtClean="0"/>
-              <a:t>06/10/2026</a:t>
+              <a:t>06/11/2026</a:t>
             </a:fld>
             <a:endParaRPr lang="en-DE"/>
           </a:p>
@@ -2100,7 +2099,7 @@
           <a:p>
             <a:fld id="{2CACDD28-0A48-0E47-898B-1110AC508CAE}" type="datetimeFigureOut">
               <a:rPr lang="en-DE" smtClean="0"/>
-              <a:t>06/10/2026</a:t>
+              <a:t>06/11/2026</a:t>
             </a:fld>
             <a:endParaRPr lang="en-DE"/>
           </a:p>
@@ -2357,7 +2356,7 @@
           <a:p>
             <a:fld id="{2CACDD28-0A48-0E47-898B-1110AC508CAE}" type="datetimeFigureOut">
               <a:rPr lang="en-DE" smtClean="0"/>
-              <a:t>06/10/2026</a:t>
+              <a:t>06/11/2026</a:t>
             </a:fld>
             <a:endParaRPr lang="en-DE"/>
           </a:p>
@@ -2570,7 +2569,7 @@
           <a:p>
             <a:fld id="{2CACDD28-0A48-0E47-898B-1110AC508CAE}" type="datetimeFigureOut">
               <a:rPr lang="en-DE" smtClean="0"/>
-              <a:t>06/10/2026</a:t>
+              <a:t>06/11/2026</a:t>
             </a:fld>
             <a:endParaRPr lang="en-DE"/>
           </a:p>
@@ -4277,276 +4276,6 @@
 </p:sld>
 </file>
 
-<file path=ppt/slides/slide3.xml><?xml version="1.0" encoding="utf-8"?>
-<p:sld xmlns:a="http://schemas.openxmlformats.org/drawingml/2006/main" xmlns:r="http://schemas.openxmlformats.org/officeDocument/2006/relationships" xmlns:p="http://schemas.openxmlformats.org/presentationml/2006/main">
-  <p:cSld>
-    <p:spTree>
-      <p:nvGrpSpPr>
-        <p:cNvPr id="1" name=""/>
-        <p:cNvGrpSpPr/>
-        <p:nvPr/>
-      </p:nvGrpSpPr>
-      <p:grpSpPr>
-        <a:xfrm>
-          <a:off x="0" y="0"/>
-          <a:ext cx="0" cy="0"/>
-          <a:chOff x="0" y="0"/>
-          <a:chExt cx="0" cy="0"/>
-        </a:xfrm>
-      </p:grpSpPr>
-      <p:pic>
-        <p:nvPicPr>
-          <p:cNvPr id="5" name="Picture 4">
-            <a:extLst>
-              <a:ext uri="{FF2B5EF4-FFF2-40B4-BE49-F238E27FC236}">
-                <a16:creationId xmlns:a16="http://schemas.microsoft.com/office/drawing/2014/main" id="{CB3A426F-6095-717A-2CB1-398C6645BF33}"/>
-              </a:ext>
-            </a:extLst>
-          </p:cNvPr>
-          <p:cNvPicPr>
-            <a:picLocks noChangeAspect="1"/>
-          </p:cNvPicPr>
-          <p:nvPr/>
-        </p:nvPicPr>
-        <p:blipFill>
-          <a:blip r:embed="rId2"/>
-          <a:srcRect r="23591"/>
-          <a:stretch>
-            <a:fillRect/>
-          </a:stretch>
-        </p:blipFill>
-        <p:spPr>
-          <a:xfrm>
-            <a:off x="2655551" y="3705491"/>
-            <a:ext cx="5565170" cy="4935178"/>
-          </a:xfrm>
-          <a:prstGeom prst="rect">
-            <a:avLst/>
-          </a:prstGeom>
-        </p:spPr>
-      </p:pic>
-      <p:pic>
-        <p:nvPicPr>
-          <p:cNvPr id="6" name="Picture 5">
-            <a:extLst>
-              <a:ext uri="{FF2B5EF4-FFF2-40B4-BE49-F238E27FC236}">
-                <a16:creationId xmlns:a16="http://schemas.microsoft.com/office/drawing/2014/main" id="{719F5DC5-B2DB-223F-1A7A-3600062AC7D4}"/>
-              </a:ext>
-            </a:extLst>
-          </p:cNvPr>
-          <p:cNvPicPr>
-            <a:picLocks noChangeAspect="1"/>
-          </p:cNvPicPr>
-          <p:nvPr/>
-        </p:nvPicPr>
-        <p:blipFill>
-          <a:blip r:embed="rId3"/>
-          <a:srcRect r="23291"/>
-          <a:stretch>
-            <a:fillRect/>
-          </a:stretch>
-        </p:blipFill>
-        <p:spPr>
-          <a:xfrm>
-            <a:off x="8399179" y="3705491"/>
-            <a:ext cx="5522082" cy="4935178"/>
-          </a:xfrm>
-          <a:prstGeom prst="rect">
-            <a:avLst/>
-          </a:prstGeom>
-        </p:spPr>
-      </p:pic>
-      <p:pic>
-        <p:nvPicPr>
-          <p:cNvPr id="7" name="Picture 6">
-            <a:extLst>
-              <a:ext uri="{FF2B5EF4-FFF2-40B4-BE49-F238E27FC236}">
-                <a16:creationId xmlns:a16="http://schemas.microsoft.com/office/drawing/2014/main" id="{3E54A11E-BE02-EA64-1463-F977354D33B3}"/>
-              </a:ext>
-            </a:extLst>
-          </p:cNvPr>
-          <p:cNvPicPr>
-            <a:picLocks noChangeAspect="1"/>
-          </p:cNvPicPr>
-          <p:nvPr/>
-        </p:nvPicPr>
-        <p:blipFill>
-          <a:blip r:embed="rId4"/>
-          <a:srcRect l="1" r="21946"/>
-          <a:stretch>
-            <a:fillRect/>
-          </a:stretch>
-        </p:blipFill>
-        <p:spPr>
-          <a:xfrm>
-            <a:off x="14099699" y="3705491"/>
-            <a:ext cx="5691462" cy="4935178"/>
-          </a:xfrm>
-          <a:prstGeom prst="rect">
-            <a:avLst/>
-          </a:prstGeom>
-        </p:spPr>
-      </p:pic>
-      <p:sp>
-        <p:nvSpPr>
-          <p:cNvPr id="8" name="Rectangle 7">
-            <a:extLst>
-              <a:ext uri="{FF2B5EF4-FFF2-40B4-BE49-F238E27FC236}">
-                <a16:creationId xmlns:a16="http://schemas.microsoft.com/office/drawing/2014/main" id="{345A3D02-4A41-A4CE-B524-D3D681774FA9}"/>
-              </a:ext>
-            </a:extLst>
-          </p:cNvPr>
-          <p:cNvSpPr/>
-          <p:nvPr/>
-        </p:nvSpPr>
-        <p:spPr>
-          <a:xfrm>
-            <a:off x="7004739" y="8271565"/>
-            <a:ext cx="1090570" cy="218114"/>
-          </a:xfrm>
-          <a:prstGeom prst="rect">
-            <a:avLst/>
-          </a:prstGeom>
-          <a:solidFill>
-            <a:schemeClr val="bg1"/>
-          </a:solidFill>
-        </p:spPr>
-        <p:style>
-          <a:lnRef idx="2">
-            <a:schemeClr val="accent1">
-              <a:shade val="15000"/>
-            </a:schemeClr>
-          </a:lnRef>
-          <a:fillRef idx="1">
-            <a:schemeClr val="accent1"/>
-          </a:fillRef>
-          <a:effectRef idx="0">
-            <a:schemeClr val="accent1"/>
-          </a:effectRef>
-          <a:fontRef idx="minor">
-            <a:schemeClr val="lt1"/>
-          </a:fontRef>
-        </p:style>
-        <p:txBody>
-          <a:bodyPr rtlCol="0" anchor="ctr"/>
-          <a:lstStyle/>
-          <a:p>
-            <a:pPr algn="ctr"/>
-            <a:endParaRPr lang="en-DE" sz="3600"/>
-          </a:p>
-        </p:txBody>
-      </p:sp>
-      <p:sp>
-        <p:nvSpPr>
-          <p:cNvPr id="9" name="Rectangle 8">
-            <a:extLst>
-              <a:ext uri="{FF2B5EF4-FFF2-40B4-BE49-F238E27FC236}">
-                <a16:creationId xmlns:a16="http://schemas.microsoft.com/office/drawing/2014/main" id="{CE399AE8-5820-561F-0797-4EB0412C6B9F}"/>
-              </a:ext>
-            </a:extLst>
-          </p:cNvPr>
-          <p:cNvSpPr/>
-          <p:nvPr/>
-        </p:nvSpPr>
-        <p:spPr>
-          <a:xfrm>
-            <a:off x="12686963" y="8271565"/>
-            <a:ext cx="1090570" cy="218114"/>
-          </a:xfrm>
-          <a:prstGeom prst="rect">
-            <a:avLst/>
-          </a:prstGeom>
-          <a:solidFill>
-            <a:schemeClr val="bg1"/>
-          </a:solidFill>
-        </p:spPr>
-        <p:style>
-          <a:lnRef idx="2">
-            <a:schemeClr val="accent1">
-              <a:shade val="15000"/>
-            </a:schemeClr>
-          </a:lnRef>
-          <a:fillRef idx="1">
-            <a:schemeClr val="accent1"/>
-          </a:fillRef>
-          <a:effectRef idx="0">
-            <a:schemeClr val="accent1"/>
-          </a:effectRef>
-          <a:fontRef idx="minor">
-            <a:schemeClr val="lt1"/>
-          </a:fontRef>
-        </p:style>
-        <p:txBody>
-          <a:bodyPr rtlCol="0" anchor="ctr"/>
-          <a:lstStyle/>
-          <a:p>
-            <a:pPr algn="ctr"/>
-            <a:endParaRPr lang="en-DE" sz="3600"/>
-          </a:p>
-        </p:txBody>
-      </p:sp>
-      <p:sp>
-        <p:nvSpPr>
-          <p:cNvPr id="10" name="Rectangle 9">
-            <a:extLst>
-              <a:ext uri="{FF2B5EF4-FFF2-40B4-BE49-F238E27FC236}">
-                <a16:creationId xmlns:a16="http://schemas.microsoft.com/office/drawing/2014/main" id="{62DB40B4-9E24-AF53-F357-E5129F83EBA0}"/>
-              </a:ext>
-            </a:extLst>
-          </p:cNvPr>
-          <p:cNvSpPr/>
-          <p:nvPr/>
-        </p:nvSpPr>
-        <p:spPr>
-          <a:xfrm>
-            <a:off x="18552217" y="8271563"/>
-            <a:ext cx="1090570" cy="218114"/>
-          </a:xfrm>
-          <a:prstGeom prst="rect">
-            <a:avLst/>
-          </a:prstGeom>
-          <a:solidFill>
-            <a:schemeClr val="bg1"/>
-          </a:solidFill>
-        </p:spPr>
-        <p:style>
-          <a:lnRef idx="2">
-            <a:schemeClr val="accent1">
-              <a:shade val="15000"/>
-            </a:schemeClr>
-          </a:lnRef>
-          <a:fillRef idx="1">
-            <a:schemeClr val="accent1"/>
-          </a:fillRef>
-          <a:effectRef idx="0">
-            <a:schemeClr val="accent1"/>
-          </a:effectRef>
-          <a:fontRef idx="minor">
-            <a:schemeClr val="lt1"/>
-          </a:fontRef>
-        </p:style>
-        <p:txBody>
-          <a:bodyPr rtlCol="0" anchor="ctr"/>
-          <a:lstStyle/>
-          <a:p>
-            <a:pPr algn="ctr"/>
-            <a:endParaRPr lang="en-DE" sz="3600"/>
-          </a:p>
-        </p:txBody>
-      </p:sp>
-    </p:spTree>
-    <p:extLst>
-      <p:ext uri="{BB962C8B-B14F-4D97-AF65-F5344CB8AC3E}">
-        <p14:creationId xmlns:p14="http://schemas.microsoft.com/office/powerpoint/2010/main" val="3600689740"/>
-      </p:ext>
-    </p:extLst>
-  </p:cSld>
-  <p:clrMapOvr>
-    <a:masterClrMapping/>
-  </p:clrMapOvr>
-</p:sld>
-</file>
-
 <file path=ppt/theme/theme1.xml><?xml version="1.0" encoding="utf-8"?>
 <a:theme xmlns:a="http://schemas.openxmlformats.org/drawingml/2006/main" name="Office 2013 - 2022 Theme">
   <a:themeElements>

</xml_diff>